<commit_message>
Keep one photo per scale test deck
The 10, 50 and 100-slide decks had a different photo on every third
slide. On the iOS 26.5 simulator WebKit links those slides to each
other's photos, which the renderer now refuses, so the scale, cache and
recovery tests could not open them. They now have one photo, on slide 3.

Co-Authored-By: Claude Opus 5.5 (1M context) <noreply@anthropic.com>
Claude-Session: https://claude.ai/code/session_01LYNH4azGoM2GCthRCCGLm4
</commit_message>
<xml_diff>
--- a/App/TaskLensTests/Fixtures/scale-10.pptx
+++ b/App/TaskLensTests/Fixtures/scale-10.pptx
@@ -3613,30 +3613,38 @@
           </a:p>
         </p:txBody>
       </p:sp>
-      <p:pic>
-        <p:nvPicPr>
-          <p:cNvPr id="3" name="Picture 2" descr="image.jpg"/>
-          <p:cNvPicPr>
-            <a:picLocks noChangeAspect="1"/>
-          </p:cNvPicPr>
+      <p:sp>
+        <p:nvSpPr>
+          <p:cNvPr id="3" name="TextBox 2"/>
+          <p:cNvSpPr txBox="1"/>
           <p:nvPr/>
-        </p:nvPicPr>
-        <p:blipFill>
-          <a:blip r:embed="rId2"/>
-          <a:stretch>
-            <a:fillRect/>
-          </a:stretch>
-        </p:blipFill>
+        </p:nvSpPr>
         <p:spPr>
           <a:xfrm>
             <a:off x="457200" y="1371600"/>
-            <a:ext cx="7315200" cy="4114800"/>
+            <a:ext cx="11277295" cy="3657600"/>
           </a:xfrm>
           <a:prstGeom prst="rect">
             <a:avLst/>
           </a:prstGeom>
+          <a:noFill/>
         </p:spPr>
-      </p:pic>
+        <p:txBody>
+          <a:bodyPr wrap="square">
+            <a:spAutoFit/>
+          </a:bodyPr>
+          <a:lstStyle/>
+          <a:p>
+            <a:pPr algn="l"/>
+            <a:r>
+              <a:rPr sz="2000">
+                <a:latin typeface="Arial"/>
+              </a:rPr>
+              <a:t>English body text for the test. English body text for the test. English body text for the test. English body text for the test. English body text for the test. English body text for the test. English body text for the test. English body text for the test. </a:t>
+            </a:r>
+          </a:p>
+        </p:txBody>
+      </p:sp>
     </p:spTree>
   </p:cSld>
   <p:clrMapOvr>
@@ -3851,30 +3859,38 @@
           </a:p>
         </p:txBody>
       </p:sp>
-      <p:pic>
-        <p:nvPicPr>
-          <p:cNvPr id="3" name="Picture 2" descr="image.jpg"/>
-          <p:cNvPicPr>
-            <a:picLocks noChangeAspect="1"/>
-          </p:cNvPicPr>
+      <p:sp>
+        <p:nvSpPr>
+          <p:cNvPr id="3" name="TextBox 2"/>
+          <p:cNvSpPr txBox="1"/>
           <p:nvPr/>
-        </p:nvPicPr>
-        <p:blipFill>
-          <a:blip r:embed="rId2"/>
-          <a:stretch>
-            <a:fillRect/>
-          </a:stretch>
-        </p:blipFill>
+        </p:nvSpPr>
         <p:spPr>
           <a:xfrm>
             <a:off x="457200" y="1371600"/>
-            <a:ext cx="7315200" cy="4114800"/>
+            <a:ext cx="11277295" cy="3657600"/>
           </a:xfrm>
           <a:prstGeom prst="rect">
             <a:avLst/>
           </a:prstGeom>
+          <a:noFill/>
         </p:spPr>
-      </p:pic>
+        <p:txBody>
+          <a:bodyPr wrap="square">
+            <a:spAutoFit/>
+          </a:bodyPr>
+          <a:lstStyle/>
+          <a:p>
+            <a:pPr algn="r" rtl="1"/>
+            <a:r>
+              <a:rPr sz="2000" lang="ar-SA">
+                <a:latin typeface="Arial"/>
+              </a:rPr>
+              <a:t>هذا نص عربي للاختبار. هذا نص عربي للاختبار. هذا نص عربي للاختبار. هذا نص عربي للاختبار. هذا نص عربي للاختبار. هذا نص عربي للاختبار. هذا نص عربي للاختبار. هذا نص عربي للاختبار. </a:t>
+            </a:r>
+          </a:p>
+        </p:txBody>
+      </p:sp>
     </p:spTree>
   </p:cSld>
   <p:clrMapOvr>

</xml_diff>